<commit_message>
Fix template deck: remove overlaps/overflow, master-safe layout
- Cover: put long meta only in the wide body placeholder; narrow
  placeholders now hold a short version string / empty (no overflow).
- Section dividers: concise "Phase N ｜ 名称" titles; descriptive
  subtitle moved to a self-drawn textbox on the light bottom band with
  band-contrasting (dark teal) text; stopped overflowing the narrow
  upper body placeholder.
- Phase/step cards: narrowed card width so the 4-up row stays inside
  the body safe area (was overrunning the right edge).
- Fixed table/callout collision on the oversharing slide and the
  source-list tables overrunning the safe area / footnote.
- Geometry self-audit (python-pptx): overlaps=0, out-of-bounds=0,
  off-canvas=0 across all 61 slides.

Co-Authored-By: Claude Opus 4.8 <noreply@anthropic.com>
Claude-Session: https://claude.ai/code/session_01UBcUziZuoBuQPVuVkCwg3R
</commit_message>
<xml_diff>
--- a/sharepoint-online-guide/SharePoint-Online活用ガイド_フェーズ1-4.pptx
+++ b/sharepoint-online-guide/SharePoint-Online活用ガイド_フェーズ1-4.pptx
@@ -10717,7 +10717,10 @@
           <a:lstStyle/>
           <a:p>
             <a:r>
-              <a:t>対象：従業員 100〜1,000 名／国内・日本語テナント／Microsoft 365 E3 主体　　版 1.0（2026-07-15）</a:t>
+              <a:rPr>
+                <a:latin typeface="游ゴシック"/>
+              </a:rPr>
+              <a:t>対象：従業員 100〜1,000 名／国内・日本語テナント／Microsoft 365 E3 主体</a:t>
             </a:r>
           </a:p>
         </p:txBody>
@@ -10762,6 +10765,9 @@
           <a:lstStyle/>
           <a:p>
             <a:r>
+              <a:rPr>
+                <a:latin typeface="游ゴシック"/>
+              </a:rPr>
               <a:t>― フェーズ1〜4 全体版（基礎・セキュリティ・ガバナンス・活用）―</a:t>
             </a:r>
           </a:p>
@@ -10783,7 +10789,10 @@
           <a:lstStyle/>
           <a:p>
             <a:r>
-              <a:t>対象：従業員 100〜1,000 名／国内・日本語テナント／Microsoft 365 E3 主体　　版 1.0（2026-07-15）</a:t>
+              <a:rPr sz="1100">
+                <a:latin typeface="游ゴシック"/>
+              </a:rPr>
+              <a:t>版 1.0（2026-07-15）</a:t>
             </a:r>
           </a:p>
         </p:txBody>
@@ -10802,11 +10811,7 @@
         <p:txBody>
           <a:bodyPr/>
           <a:lstStyle/>
-          <a:p>
-            <a:r>
-              <a:t>対象：従業員 100〜1,000 名／国内・日本語テナント／Microsoft 365 E3 主体　　版 1.0（2026-07-15）</a:t>
-            </a:r>
-          </a:p>
+          <a:p/>
         </p:txBody>
       </p:sp>
     </p:spTree>
@@ -20536,14 +20541,7 @@
         <p:txBody>
           <a:bodyPr/>
           <a:lstStyle/>
-          <a:p>
-            <a:r>
-              <a:rPr>
-                <a:latin typeface="游ゴシック"/>
-              </a:rPr>
-              <a:t>E3で今すぐ／追加ライセンスで拡張</a:t>
-            </a:r>
-          </a:p>
+          <a:p/>
         </p:txBody>
       </p:sp>
       <p:sp>
@@ -20565,7 +20563,54 @@
               <a:rPr>
                 <a:latin typeface="游ゴシック"/>
               </a:rPr>
-              <a:t>Phase 2　セキュリティ：秘密度ラベル・監査・情報保護</a:t>
+              <a:t>Phase 2 ｜ セキュリティ：ラベル・監査・情報保護</a:t>
+            </a:r>
+          </a:p>
+        </p:txBody>
+      </p:sp>
+      <p:sp>
+        <p:nvSpPr>
+          <p:cNvPr id="4" name="TextBox 3"/>
+          <p:cNvSpPr txBox="1"/>
+          <p:nvPr/>
+        </p:nvSpPr>
+        <p:spPr>
+          <a:xfrm>
+            <a:off x="1097280" y="5138928"/>
+            <a:ext cx="11247120" cy="384048"/>
+          </a:xfrm>
+          <a:prstGeom prst="rect">
+            <a:avLst/>
+          </a:prstGeom>
+          <a:noFill/>
+        </p:spPr>
+        <p:txBody>
+          <a:bodyPr wrap="square" anchor="ctr" lIns="0" rIns="0" tIns="0" bIns="0">
+            <a:spAutoFit/>
+          </a:bodyPr>
+          <a:lstStyle/>
+          <a:p>
+            <a:pPr algn="l">
+              <a:lnSpc>
+                <a:spcPct val="108000"/>
+              </a:lnSpc>
+              <a:spcBef>
+                <a:spcPts val="0"/>
+              </a:spcBef>
+              <a:spcAft>
+                <a:spcPts val="300"/>
+              </a:spcAft>
+            </a:pPr>
+            <a:r>
+              <a:rPr sz="1550" b="0">
+                <a:solidFill>
+                  <a:srgbClr val="1B5C80"/>
+                </a:solidFill>
+                <a:latin typeface="游ゴシック"/>
+                <a:ea typeface="游ゴシック"/>
+                <a:cs typeface="游ゴシック"/>
+              </a:rPr>
+              <a:t>秘密度ラベル・DLP・監査・条件付きアクセス（E3で着手／E5で拡張）</a:t>
             </a:r>
           </a:p>
         </p:txBody>
@@ -26351,7 +26396,7 @@
         <p:spPr>
           <a:xfrm>
             <a:off x="822960" y="1417320"/>
-            <a:ext cx="2880360" cy="3108960"/>
+            <a:ext cx="2816352" cy="3108960"/>
           </a:xfrm>
           <a:prstGeom prst="roundRect">
             <a:avLst>
@@ -26399,7 +26444,7 @@
         <p:spPr>
           <a:xfrm>
             <a:off x="822960" y="1417320"/>
-            <a:ext cx="2880360" cy="566928"/>
+            <a:ext cx="2816352" cy="566928"/>
           </a:xfrm>
           <a:prstGeom prst="roundRect">
             <a:avLst>
@@ -26445,7 +26490,7 @@
         <p:spPr>
           <a:xfrm>
             <a:off x="822960" y="1490472"/>
-            <a:ext cx="2880360" cy="420624"/>
+            <a:ext cx="2816352" cy="420624"/>
           </a:xfrm>
           <a:prstGeom prst="rect">
             <a:avLst/>
@@ -26492,7 +26537,7 @@
         <p:spPr>
           <a:xfrm>
             <a:off x="969264" y="2167128"/>
-            <a:ext cx="2587752" cy="640080"/>
+            <a:ext cx="2523744" cy="640080"/>
           </a:xfrm>
           <a:prstGeom prst="rect">
             <a:avLst/>
@@ -26539,7 +26584,7 @@
         <p:spPr>
           <a:xfrm>
             <a:off x="1005840" y="2880360"/>
-            <a:ext cx="2514600" cy="1371600"/>
+            <a:ext cx="2450592" cy="1371600"/>
           </a:xfrm>
           <a:prstGeom prst="rect">
             <a:avLst/>
@@ -26585,8 +26630,8 @@
         </p:nvSpPr>
         <p:spPr>
           <a:xfrm>
-            <a:off x="3849624" y="1417320"/>
-            <a:ext cx="2880360" cy="3108960"/>
+            <a:off x="3785616" y="1417320"/>
+            <a:ext cx="2816352" cy="3108960"/>
           </a:xfrm>
           <a:prstGeom prst="roundRect">
             <a:avLst>
@@ -26633,8 +26678,8 @@
         </p:nvSpPr>
         <p:spPr>
           <a:xfrm>
-            <a:off x="3849624" y="1417320"/>
-            <a:ext cx="2880360" cy="566928"/>
+            <a:off x="3785616" y="1417320"/>
+            <a:ext cx="2816352" cy="566928"/>
           </a:xfrm>
           <a:prstGeom prst="roundRect">
             <a:avLst>
@@ -26679,8 +26724,8 @@
         </p:nvSpPr>
         <p:spPr>
           <a:xfrm>
-            <a:off x="3849624" y="1490472"/>
-            <a:ext cx="2880360" cy="420624"/>
+            <a:off x="3785616" y="1490472"/>
+            <a:ext cx="2816352" cy="420624"/>
           </a:xfrm>
           <a:prstGeom prst="rect">
             <a:avLst/>
@@ -26726,8 +26771,8 @@
         </p:nvSpPr>
         <p:spPr>
           <a:xfrm>
-            <a:off x="3995928" y="2167128"/>
-            <a:ext cx="2587752" cy="640080"/>
+            <a:off x="3931920" y="2167128"/>
+            <a:ext cx="2523744" cy="640080"/>
           </a:xfrm>
           <a:prstGeom prst="rect">
             <a:avLst/>
@@ -26773,8 +26818,8 @@
         </p:nvSpPr>
         <p:spPr>
           <a:xfrm>
-            <a:off x="4032504" y="2880360"/>
-            <a:ext cx="2514600" cy="1371600"/>
+            <a:off x="3968496" y="2880360"/>
+            <a:ext cx="2450592" cy="1371600"/>
           </a:xfrm>
           <a:prstGeom prst="rect">
             <a:avLst/>
@@ -26820,8 +26865,8 @@
         </p:nvSpPr>
         <p:spPr>
           <a:xfrm>
-            <a:off x="6876288" y="1417320"/>
-            <a:ext cx="2880360" cy="3108960"/>
+            <a:off x="6748272" y="1417320"/>
+            <a:ext cx="2816352" cy="3108960"/>
           </a:xfrm>
           <a:prstGeom prst="roundRect">
             <a:avLst>
@@ -26868,8 +26913,8 @@
         </p:nvSpPr>
         <p:spPr>
           <a:xfrm>
-            <a:off x="6876288" y="1417320"/>
-            <a:ext cx="2880360" cy="566928"/>
+            <a:off x="6748272" y="1417320"/>
+            <a:ext cx="2816352" cy="566928"/>
           </a:xfrm>
           <a:prstGeom prst="roundRect">
             <a:avLst>
@@ -26914,8 +26959,8 @@
         </p:nvSpPr>
         <p:spPr>
           <a:xfrm>
-            <a:off x="6876288" y="1490472"/>
-            <a:ext cx="2880360" cy="420624"/>
+            <a:off x="6748272" y="1490472"/>
+            <a:ext cx="2816352" cy="420624"/>
           </a:xfrm>
           <a:prstGeom prst="rect">
             <a:avLst/>
@@ -26961,8 +27006,8 @@
         </p:nvSpPr>
         <p:spPr>
           <a:xfrm>
-            <a:off x="7022592" y="2167128"/>
-            <a:ext cx="2587752" cy="640080"/>
+            <a:off x="6894576" y="2167128"/>
+            <a:ext cx="2523744" cy="640080"/>
           </a:xfrm>
           <a:prstGeom prst="rect">
             <a:avLst/>
@@ -27008,8 +27053,8 @@
         </p:nvSpPr>
         <p:spPr>
           <a:xfrm>
-            <a:off x="7059168" y="2880360"/>
-            <a:ext cx="2514600" cy="1371600"/>
+            <a:off x="6931152" y="2880360"/>
+            <a:ext cx="2450592" cy="1371600"/>
           </a:xfrm>
           <a:prstGeom prst="rect">
             <a:avLst/>
@@ -27055,8 +27100,8 @@
         </p:nvSpPr>
         <p:spPr>
           <a:xfrm>
-            <a:off x="9902952" y="1417320"/>
-            <a:ext cx="2880360" cy="3108960"/>
+            <a:off x="9710928" y="1417320"/>
+            <a:ext cx="2816352" cy="3108960"/>
           </a:xfrm>
           <a:prstGeom prst="roundRect">
             <a:avLst>
@@ -27103,8 +27148,8 @@
         </p:nvSpPr>
         <p:spPr>
           <a:xfrm>
-            <a:off x="9902952" y="1417320"/>
-            <a:ext cx="2880360" cy="566928"/>
+            <a:off x="9710928" y="1417320"/>
+            <a:ext cx="2816352" cy="566928"/>
           </a:xfrm>
           <a:prstGeom prst="roundRect">
             <a:avLst>
@@ -27149,8 +27194,8 @@
         </p:nvSpPr>
         <p:spPr>
           <a:xfrm>
-            <a:off x="9902952" y="1490472"/>
-            <a:ext cx="2880360" cy="420624"/>
+            <a:off x="9710928" y="1490472"/>
+            <a:ext cx="2816352" cy="420624"/>
           </a:xfrm>
           <a:prstGeom prst="rect">
             <a:avLst/>
@@ -27196,8 +27241,8 @@
         </p:nvSpPr>
         <p:spPr>
           <a:xfrm>
-            <a:off x="10049256" y="2167128"/>
-            <a:ext cx="2587752" cy="640080"/>
+            <a:off x="9857232" y="2167128"/>
+            <a:ext cx="2523744" cy="640080"/>
           </a:xfrm>
           <a:prstGeom prst="rect">
             <a:avLst/>
@@ -27243,8 +27288,8 @@
         </p:nvSpPr>
         <p:spPr>
           <a:xfrm>
-            <a:off x="10085832" y="2880360"/>
-            <a:ext cx="2514600" cy="1371600"/>
+            <a:off x="9893808" y="2880360"/>
+            <a:ext cx="2450592" cy="1371600"/>
           </a:xfrm>
           <a:prstGeom prst="rect">
             <a:avLst/>
@@ -27414,14 +27459,7 @@
         <p:txBody>
           <a:bodyPr/>
           <a:lstStyle/>
-          <a:p>
-            <a:r>
-              <a:rPr>
-                <a:latin typeface="游ゴシック"/>
-              </a:rPr>
-              <a:t>作らせ方の統制／ライフサイクル／過剰共有の是正</a:t>
-            </a:r>
-          </a:p>
+          <a:p/>
         </p:txBody>
       </p:sp>
       <p:sp>
@@ -27443,7 +27481,54 @@
               <a:rPr>
                 <a:latin typeface="游ゴシック"/>
               </a:rPr>
-              <a:t>Phase 3　ガバナンス・運用</a:t>
+              <a:t>Phase 3 ｜ ガバナンス・運用</a:t>
+            </a:r>
+          </a:p>
+        </p:txBody>
+      </p:sp>
+      <p:sp>
+        <p:nvSpPr>
+          <p:cNvPr id="4" name="TextBox 3"/>
+          <p:cNvSpPr txBox="1"/>
+          <p:nvPr/>
+        </p:nvSpPr>
+        <p:spPr>
+          <a:xfrm>
+            <a:off x="1097280" y="5138928"/>
+            <a:ext cx="11247120" cy="384048"/>
+          </a:xfrm>
+          <a:prstGeom prst="rect">
+            <a:avLst/>
+          </a:prstGeom>
+          <a:noFill/>
+        </p:spPr>
+        <p:txBody>
+          <a:bodyPr wrap="square" anchor="ctr" lIns="0" rIns="0" tIns="0" bIns="0">
+            <a:spAutoFit/>
+          </a:bodyPr>
+          <a:lstStyle/>
+          <a:p>
+            <a:pPr algn="l">
+              <a:lnSpc>
+                <a:spcPct val="108000"/>
+              </a:lnSpc>
+              <a:spcBef>
+                <a:spcPts val="0"/>
+              </a:spcBef>
+              <a:spcAft>
+                <a:spcPts val="300"/>
+              </a:spcAft>
+            </a:pPr>
+            <a:r>
+              <a:rPr sz="1550" b="0">
+                <a:solidFill>
+                  <a:srgbClr val="1B5C80"/>
+                </a:solidFill>
+                <a:latin typeface="游ゴシック"/>
+                <a:ea typeface="游ゴシック"/>
+                <a:cs typeface="游ゴシック"/>
+              </a:rPr>
+              <a:t>作らせ方の統制／ライフサイクル／過剰共有の是正／運用体制</a:t>
             </a:r>
           </a:p>
         </p:txBody>
@@ -30447,7 +30532,7 @@
         </p:nvSpPr>
         <p:spPr>
           <a:xfrm>
-            <a:off x="822960" y="4251960"/>
+            <a:off x="822960" y="4389120"/>
             <a:ext cx="11793855" cy="822960"/>
           </a:xfrm>
           <a:prstGeom prst="roundRect">
@@ -30495,7 +30580,7 @@
         </p:nvSpPr>
         <p:spPr>
           <a:xfrm>
-            <a:off x="1024128" y="4361688"/>
+            <a:off x="1024128" y="4498848"/>
             <a:ext cx="11391519" cy="603504"/>
           </a:xfrm>
           <a:prstGeom prst="rect">
@@ -31378,14 +31463,7 @@
         <p:txBody>
           <a:bodyPr/>
           <a:lstStyle/>
-          <a:p>
-            <a:r>
-              <a:rPr>
-                <a:latin typeface="游ゴシック"/>
-              </a:rPr>
-              <a:t>Copilot／Power Platform ― 付属機能と追加課金を区別</a:t>
-            </a:r>
-          </a:p>
+          <a:p/>
         </p:txBody>
       </p:sp>
       <p:sp>
@@ -31407,7 +31485,54 @@
               <a:rPr>
                 <a:latin typeface="游ゴシック"/>
               </a:rPr>
-              <a:t>Phase 4　高度化・活用（任意）</a:t>
+              <a:t>Phase 4 ｜ 高度化・活用（任意）</a:t>
+            </a:r>
+          </a:p>
+        </p:txBody>
+      </p:sp>
+      <p:sp>
+        <p:nvSpPr>
+          <p:cNvPr id="4" name="TextBox 3"/>
+          <p:cNvSpPr txBox="1"/>
+          <p:nvPr/>
+        </p:nvSpPr>
+        <p:spPr>
+          <a:xfrm>
+            <a:off x="1097280" y="5138928"/>
+            <a:ext cx="11247120" cy="384048"/>
+          </a:xfrm>
+          <a:prstGeom prst="rect">
+            <a:avLst/>
+          </a:prstGeom>
+          <a:noFill/>
+        </p:spPr>
+        <p:txBody>
+          <a:bodyPr wrap="square" anchor="ctr" lIns="0" rIns="0" tIns="0" bIns="0">
+            <a:spAutoFit/>
+          </a:bodyPr>
+          <a:lstStyle/>
+          <a:p>
+            <a:pPr algn="l">
+              <a:lnSpc>
+                <a:spcPct val="108000"/>
+              </a:lnSpc>
+              <a:spcBef>
+                <a:spcPts val="0"/>
+              </a:spcBef>
+              <a:spcAft>
+                <a:spcPts val="300"/>
+              </a:spcAft>
+            </a:pPr>
+            <a:r>
+              <a:rPr sz="1550" b="0">
+                <a:solidFill>
+                  <a:srgbClr val="1B5C80"/>
+                </a:solidFill>
+                <a:latin typeface="游ゴシック"/>
+                <a:ea typeface="游ゴシック"/>
+                <a:cs typeface="游ゴシック"/>
+              </a:rPr>
+              <a:t>Copilot／Power Platform ― 付属機能と追加課金を区別して段階導入</a:t>
             </a:r>
           </a:p>
         </p:txBody>
@@ -31722,14 +31847,7 @@
         <p:txBody>
           <a:bodyPr/>
           <a:lstStyle/>
-          <a:p>
-            <a:r>
-              <a:rPr>
-                <a:latin typeface="游ゴシック"/>
-              </a:rPr>
-              <a:t>どこに何を置くか／サイトの選び方／グループ・権限</a:t>
-            </a:r>
-          </a:p>
+          <a:p/>
         </p:txBody>
       </p:sp>
       <p:sp>
@@ -31751,7 +31869,54 @@
               <a:rPr>
                 <a:latin typeface="游ゴシック"/>
               </a:rPr>
-              <a:t>Phase 1　基礎：構成・棲み分け・権限設計</a:t>
+              <a:t>Phase 1 ｜ 基礎：構成・棲み分けと権限設計</a:t>
+            </a:r>
+          </a:p>
+        </p:txBody>
+      </p:sp>
+      <p:sp>
+        <p:nvSpPr>
+          <p:cNvPr id="4" name="TextBox 3"/>
+          <p:cNvSpPr txBox="1"/>
+          <p:nvPr/>
+        </p:nvSpPr>
+        <p:spPr>
+          <a:xfrm>
+            <a:off x="1097280" y="5138928"/>
+            <a:ext cx="11247120" cy="384048"/>
+          </a:xfrm>
+          <a:prstGeom prst="rect">
+            <a:avLst/>
+          </a:prstGeom>
+          <a:noFill/>
+        </p:spPr>
+        <p:txBody>
+          <a:bodyPr wrap="square" anchor="ctr" lIns="0" rIns="0" tIns="0" bIns="0">
+            <a:spAutoFit/>
+          </a:bodyPr>
+          <a:lstStyle/>
+          <a:p>
+            <a:pPr algn="l">
+              <a:lnSpc>
+                <a:spcPct val="108000"/>
+              </a:lnSpc>
+              <a:spcBef>
+                <a:spcPts val="0"/>
+              </a:spcBef>
+              <a:spcAft>
+                <a:spcPts val="300"/>
+              </a:spcAft>
+            </a:pPr>
+            <a:r>
+              <a:rPr sz="1550" b="0">
+                <a:solidFill>
+                  <a:srgbClr val="1B5C80"/>
+                </a:solidFill>
+                <a:latin typeface="游ゴシック"/>
+                <a:ea typeface="游ゴシック"/>
+                <a:cs typeface="游ゴシック"/>
+              </a:rPr>
+              <a:t>どこに何を置くか／サイトの選び方／グループ・権限設計・移行</a:t>
             </a:r>
           </a:p>
         </p:txBody>
@@ -35016,7 +35181,7 @@
         <p:spPr>
           <a:xfrm>
             <a:off x="822960" y="1554480"/>
-            <a:ext cx="2880360" cy="3017520"/>
+            <a:ext cx="2816352" cy="3017520"/>
           </a:xfrm>
           <a:prstGeom prst="roundRect">
             <a:avLst>
@@ -35064,7 +35229,7 @@
         <p:spPr>
           <a:xfrm>
             <a:off x="822960" y="1554480"/>
-            <a:ext cx="2880360" cy="868680"/>
+            <a:ext cx="2816352" cy="868680"/>
           </a:xfrm>
           <a:prstGeom prst="roundRect">
             <a:avLst>
@@ -35110,7 +35275,7 @@
         <p:spPr>
           <a:xfrm>
             <a:off x="822960" y="1645920"/>
-            <a:ext cx="2880360" cy="365760"/>
+            <a:ext cx="2816352" cy="365760"/>
           </a:xfrm>
           <a:prstGeom prst="rect">
             <a:avLst/>
@@ -35157,7 +35322,7 @@
         <p:spPr>
           <a:xfrm>
             <a:off x="822960" y="1993392"/>
-            <a:ext cx="2880360" cy="384048"/>
+            <a:ext cx="2816352" cy="384048"/>
           </a:xfrm>
           <a:prstGeom prst="rect">
             <a:avLst/>
@@ -35204,7 +35369,7 @@
         <p:spPr>
           <a:xfrm>
             <a:off x="1024128" y="2606040"/>
-            <a:ext cx="2514600" cy="1737360"/>
+            <a:ext cx="2450592" cy="1737360"/>
           </a:xfrm>
           <a:prstGeom prst="rect">
             <a:avLst/>
@@ -35354,7 +35519,7 @@
         </p:nvSpPr>
         <p:spPr>
           <a:xfrm>
-            <a:off x="3685032" y="2651760"/>
+            <a:off x="3621024" y="2651760"/>
             <a:ext cx="292608" cy="548640"/>
           </a:xfrm>
           <a:prstGeom prst="rect">
@@ -35401,8 +35566,8 @@
         </p:nvSpPr>
         <p:spPr>
           <a:xfrm>
-            <a:off x="3849624" y="1554480"/>
-            <a:ext cx="2880360" cy="3017520"/>
+            <a:off x="3785616" y="1554480"/>
+            <a:ext cx="2816352" cy="3017520"/>
           </a:xfrm>
           <a:prstGeom prst="roundRect">
             <a:avLst>
@@ -35449,8 +35614,8 @@
         </p:nvSpPr>
         <p:spPr>
           <a:xfrm>
-            <a:off x="3849624" y="1554480"/>
-            <a:ext cx="2880360" cy="868680"/>
+            <a:off x="3785616" y="1554480"/>
+            <a:ext cx="2816352" cy="868680"/>
           </a:xfrm>
           <a:prstGeom prst="roundRect">
             <a:avLst>
@@ -35495,8 +35660,8 @@
         </p:nvSpPr>
         <p:spPr>
           <a:xfrm>
-            <a:off x="3849624" y="1645920"/>
-            <a:ext cx="2880360" cy="365760"/>
+            <a:off x="3785616" y="1645920"/>
+            <a:ext cx="2816352" cy="365760"/>
           </a:xfrm>
           <a:prstGeom prst="rect">
             <a:avLst/>
@@ -35542,8 +35707,8 @@
         </p:nvSpPr>
         <p:spPr>
           <a:xfrm>
-            <a:off x="3849624" y="1993392"/>
-            <a:ext cx="2880360" cy="384048"/>
+            <a:off x="3785616" y="1993392"/>
+            <a:ext cx="2816352" cy="384048"/>
           </a:xfrm>
           <a:prstGeom prst="rect">
             <a:avLst/>
@@ -35589,8 +35754,8 @@
         </p:nvSpPr>
         <p:spPr>
           <a:xfrm>
-            <a:off x="4050792" y="2606040"/>
-            <a:ext cx="2514600" cy="1737360"/>
+            <a:off x="3986784" y="2606040"/>
+            <a:ext cx="2450592" cy="1737360"/>
           </a:xfrm>
           <a:prstGeom prst="rect">
             <a:avLst/>
@@ -35740,7 +35905,7 @@
         </p:nvSpPr>
         <p:spPr>
           <a:xfrm>
-            <a:off x="6711696" y="2651760"/>
+            <a:off x="6583680" y="2651760"/>
             <a:ext cx="292608" cy="548640"/>
           </a:xfrm>
           <a:prstGeom prst="rect">
@@ -35787,8 +35952,8 @@
         </p:nvSpPr>
         <p:spPr>
           <a:xfrm>
-            <a:off x="6876288" y="1554480"/>
-            <a:ext cx="2880360" cy="3017520"/>
+            <a:off x="6748272" y="1554480"/>
+            <a:ext cx="2816352" cy="3017520"/>
           </a:xfrm>
           <a:prstGeom prst="roundRect">
             <a:avLst>
@@ -35835,8 +36000,8 @@
         </p:nvSpPr>
         <p:spPr>
           <a:xfrm>
-            <a:off x="6876288" y="1554480"/>
-            <a:ext cx="2880360" cy="868680"/>
+            <a:off x="6748272" y="1554480"/>
+            <a:ext cx="2816352" cy="868680"/>
           </a:xfrm>
           <a:prstGeom prst="roundRect">
             <a:avLst>
@@ -35881,8 +36046,8 @@
         </p:nvSpPr>
         <p:spPr>
           <a:xfrm>
-            <a:off x="6876288" y="1645920"/>
-            <a:ext cx="2880360" cy="365760"/>
+            <a:off x="6748272" y="1645920"/>
+            <a:ext cx="2816352" cy="365760"/>
           </a:xfrm>
           <a:prstGeom prst="rect">
             <a:avLst/>
@@ -35928,8 +36093,8 @@
         </p:nvSpPr>
         <p:spPr>
           <a:xfrm>
-            <a:off x="6876288" y="1993392"/>
-            <a:ext cx="2880360" cy="384048"/>
+            <a:off x="6748272" y="1993392"/>
+            <a:ext cx="2816352" cy="384048"/>
           </a:xfrm>
           <a:prstGeom prst="rect">
             <a:avLst/>
@@ -35975,8 +36140,8 @@
         </p:nvSpPr>
         <p:spPr>
           <a:xfrm>
-            <a:off x="7077456" y="2606040"/>
-            <a:ext cx="2514600" cy="1737360"/>
+            <a:off x="6949440" y="2606040"/>
+            <a:ext cx="2450592" cy="1737360"/>
           </a:xfrm>
           <a:prstGeom prst="rect">
             <a:avLst/>
@@ -36126,7 +36291,7 @@
         </p:nvSpPr>
         <p:spPr>
           <a:xfrm>
-            <a:off x="9738360" y="2651760"/>
+            <a:off x="9546336" y="2651760"/>
             <a:ext cx="292608" cy="548640"/>
           </a:xfrm>
           <a:prstGeom prst="rect">
@@ -36173,8 +36338,8 @@
         </p:nvSpPr>
         <p:spPr>
           <a:xfrm>
-            <a:off x="9902952" y="1554480"/>
-            <a:ext cx="2880360" cy="3017520"/>
+            <a:off x="9710928" y="1554480"/>
+            <a:ext cx="2816352" cy="3017520"/>
           </a:xfrm>
           <a:prstGeom prst="roundRect">
             <a:avLst>
@@ -36221,8 +36386,8 @@
         </p:nvSpPr>
         <p:spPr>
           <a:xfrm>
-            <a:off x="9902952" y="1554480"/>
-            <a:ext cx="2880360" cy="868680"/>
+            <a:off x="9710928" y="1554480"/>
+            <a:ext cx="2816352" cy="868680"/>
           </a:xfrm>
           <a:prstGeom prst="roundRect">
             <a:avLst>
@@ -36267,8 +36432,8 @@
         </p:nvSpPr>
         <p:spPr>
           <a:xfrm>
-            <a:off x="9902952" y="1645920"/>
-            <a:ext cx="2880360" cy="365760"/>
+            <a:off x="9710928" y="1645920"/>
+            <a:ext cx="2816352" cy="365760"/>
           </a:xfrm>
           <a:prstGeom prst="rect">
             <a:avLst/>
@@ -36314,8 +36479,8 @@
         </p:nvSpPr>
         <p:spPr>
           <a:xfrm>
-            <a:off x="9902952" y="1993392"/>
-            <a:ext cx="2880360" cy="384048"/>
+            <a:off x="9710928" y="1993392"/>
+            <a:ext cx="2816352" cy="384048"/>
           </a:xfrm>
           <a:prstGeom prst="rect">
             <a:avLst/>
@@ -36361,8 +36526,8 @@
         </p:nvSpPr>
         <p:spPr>
           <a:xfrm>
-            <a:off x="10104120" y="2606040"/>
-            <a:ext cx="2514600" cy="1737360"/>
+            <a:off x="9912096" y="2606040"/>
+            <a:ext cx="2450592" cy="1737360"/>
           </a:xfrm>
           <a:prstGeom prst="rect">
             <a:avLst/>
@@ -38027,7 +38192,7 @@
         </p:nvGraphicFramePr>
         <p:xfrm>
           <a:off x="822960" y="1143000"/>
-          <a:ext cx="5532120" cy="5833872"/>
+          <a:ext cx="5532119" cy="5120640"/>
         </p:xfrm>
         <a:graphic>
           <a:graphicData uri="http://schemas.openxmlformats.org/drawingml/2006/table">
@@ -38036,8 +38201,8 @@
                 <a:tableStyleId>{5C22544A-7EE6-4342-B048-85BDC9FD1C3A}</a:tableStyleId>
               </a:tblPr>
               <a:tblGrid>
-                <a:gridCol w="2212848"/>
-                <a:gridCol w="3319272"/>
+                <a:gridCol w="663854"/>
+                <a:gridCol w="4868265"/>
               </a:tblGrid>
               <a:tr h="365760">
                 <a:tc>
@@ -38099,7 +38264,7 @@
                   </a:tcPr>
                 </a:tc>
               </a:tr>
-              <a:tr h="420624">
+              <a:tr h="365760">
                 <a:tc>
                   <a:txBody>
                     <a:bodyPr wrap="square"/>
@@ -38159,7 +38324,7 @@
                   </a:tcPr>
                 </a:tc>
               </a:tr>
-              <a:tr h="420624">
+              <a:tr h="365760">
                 <a:tc>
                   <a:txBody>
                     <a:bodyPr wrap="square"/>
@@ -38219,7 +38384,7 @@
                   </a:tcPr>
                 </a:tc>
               </a:tr>
-              <a:tr h="420624">
+              <a:tr h="365760">
                 <a:tc>
                   <a:txBody>
                     <a:bodyPr wrap="square"/>
@@ -38279,7 +38444,7 @@
                   </a:tcPr>
                 </a:tc>
               </a:tr>
-              <a:tr h="420624">
+              <a:tr h="365760">
                 <a:tc>
                   <a:txBody>
                     <a:bodyPr wrap="square"/>
@@ -38339,7 +38504,7 @@
                   </a:tcPr>
                 </a:tc>
               </a:tr>
-              <a:tr h="420624">
+              <a:tr h="365760">
                 <a:tc>
                   <a:txBody>
                     <a:bodyPr wrap="square"/>
@@ -38399,7 +38564,7 @@
                   </a:tcPr>
                 </a:tc>
               </a:tr>
-              <a:tr h="420624">
+              <a:tr h="365760">
                 <a:tc>
                   <a:txBody>
                     <a:bodyPr wrap="square"/>
@@ -38459,7 +38624,7 @@
                   </a:tcPr>
                 </a:tc>
               </a:tr>
-              <a:tr h="420624">
+              <a:tr h="365760">
                 <a:tc>
                   <a:txBody>
                     <a:bodyPr wrap="square"/>
@@ -38519,7 +38684,7 @@
                   </a:tcPr>
                 </a:tc>
               </a:tr>
-              <a:tr h="420624">
+              <a:tr h="365760">
                 <a:tc>
                   <a:txBody>
                     <a:bodyPr wrap="square"/>
@@ -38579,7 +38744,7 @@
                   </a:tcPr>
                 </a:tc>
               </a:tr>
-              <a:tr h="420624">
+              <a:tr h="365760">
                 <a:tc>
                   <a:txBody>
                     <a:bodyPr wrap="square"/>
@@ -38639,7 +38804,7 @@
                   </a:tcPr>
                 </a:tc>
               </a:tr>
-              <a:tr h="420624">
+              <a:tr h="365760">
                 <a:tc>
                   <a:txBody>
                     <a:bodyPr wrap="square"/>
@@ -38699,7 +38864,7 @@
                   </a:tcPr>
                 </a:tc>
               </a:tr>
-              <a:tr h="420624">
+              <a:tr h="365760">
                 <a:tc>
                   <a:txBody>
                     <a:bodyPr wrap="square"/>
@@ -38759,7 +38924,7 @@
                   </a:tcPr>
                 </a:tc>
               </a:tr>
-              <a:tr h="420624">
+              <a:tr h="365760">
                 <a:tc>
                   <a:txBody>
                     <a:bodyPr wrap="square"/>
@@ -38819,7 +38984,7 @@
                   </a:tcPr>
                 </a:tc>
               </a:tr>
-              <a:tr h="420624">
+              <a:tr h="365760">
                 <a:tc>
                   <a:txBody>
                     <a:bodyPr wrap="square"/>
@@ -38893,7 +39058,7 @@
         </p:nvGraphicFramePr>
         <p:xfrm>
           <a:off x="6812280" y="1143000"/>
-          <a:ext cx="5532120" cy="5833872"/>
+          <a:ext cx="5532119" cy="5120640"/>
         </p:xfrm>
         <a:graphic>
           <a:graphicData uri="http://schemas.openxmlformats.org/drawingml/2006/table">
@@ -38902,8 +39067,8 @@
                 <a:tableStyleId>{5C22544A-7EE6-4342-B048-85BDC9FD1C3A}</a:tableStyleId>
               </a:tblPr>
               <a:tblGrid>
-                <a:gridCol w="2212848"/>
-                <a:gridCol w="3319272"/>
+                <a:gridCol w="663854"/>
+                <a:gridCol w="4868265"/>
               </a:tblGrid>
               <a:tr h="365760">
                 <a:tc>
@@ -38965,7 +39130,7 @@
                   </a:tcPr>
                 </a:tc>
               </a:tr>
-              <a:tr h="420624">
+              <a:tr h="365760">
                 <a:tc>
                   <a:txBody>
                     <a:bodyPr wrap="square"/>
@@ -39025,7 +39190,7 @@
                   </a:tcPr>
                 </a:tc>
               </a:tr>
-              <a:tr h="420624">
+              <a:tr h="365760">
                 <a:tc>
                   <a:txBody>
                     <a:bodyPr wrap="square"/>
@@ -39085,7 +39250,7 @@
                   </a:tcPr>
                 </a:tc>
               </a:tr>
-              <a:tr h="420624">
+              <a:tr h="365760">
                 <a:tc>
                   <a:txBody>
                     <a:bodyPr wrap="square"/>
@@ -39145,7 +39310,7 @@
                   </a:tcPr>
                 </a:tc>
               </a:tr>
-              <a:tr h="420624">
+              <a:tr h="365760">
                 <a:tc>
                   <a:txBody>
                     <a:bodyPr wrap="square"/>
@@ -39205,7 +39370,7 @@
                   </a:tcPr>
                 </a:tc>
               </a:tr>
-              <a:tr h="420624">
+              <a:tr h="365760">
                 <a:tc>
                   <a:txBody>
                     <a:bodyPr wrap="square"/>
@@ -39265,7 +39430,7 @@
                   </a:tcPr>
                 </a:tc>
               </a:tr>
-              <a:tr h="420624">
+              <a:tr h="365760">
                 <a:tc>
                   <a:txBody>
                     <a:bodyPr wrap="square"/>
@@ -39325,7 +39490,7 @@
                   </a:tcPr>
                 </a:tc>
               </a:tr>
-              <a:tr h="420624">
+              <a:tr h="365760">
                 <a:tc>
                   <a:txBody>
                     <a:bodyPr wrap="square"/>
@@ -39385,7 +39550,7 @@
                   </a:tcPr>
                 </a:tc>
               </a:tr>
-              <a:tr h="420624">
+              <a:tr h="365760">
                 <a:tc>
                   <a:txBody>
                     <a:bodyPr wrap="square"/>
@@ -39445,7 +39610,7 @@
                   </a:tcPr>
                 </a:tc>
               </a:tr>
-              <a:tr h="420624">
+              <a:tr h="365760">
                 <a:tc>
                   <a:txBody>
                     <a:bodyPr wrap="square"/>
@@ -39505,7 +39670,7 @@
                   </a:tcPr>
                 </a:tc>
               </a:tr>
-              <a:tr h="420624">
+              <a:tr h="365760">
                 <a:tc>
                   <a:txBody>
                     <a:bodyPr wrap="square"/>
@@ -39565,7 +39730,7 @@
                   </a:tcPr>
                 </a:tc>
               </a:tr>
-              <a:tr h="420624">
+              <a:tr h="365760">
                 <a:tc>
                   <a:txBody>
                     <a:bodyPr wrap="square"/>
@@ -39625,7 +39790,7 @@
                   </a:tcPr>
                 </a:tc>
               </a:tr>
-              <a:tr h="420624">
+              <a:tr h="365760">
                 <a:tc>
                   <a:txBody>
                     <a:bodyPr wrap="square"/>
@@ -39685,7 +39850,7 @@
                   </a:tcPr>
                 </a:tc>
               </a:tr>
-              <a:tr h="420624">
+              <a:tr h="365760">
                 <a:tc>
                   <a:txBody>
                     <a:bodyPr wrap="square"/>
@@ -39757,7 +39922,7 @@
         </p:nvSpPr>
         <p:spPr>
           <a:xfrm>
-            <a:off x="822960" y="6446520"/>
+            <a:off x="822960" y="6492240"/>
             <a:ext cx="11793855" cy="274320"/>
           </a:xfrm>
           <a:prstGeom prst="rect">
@@ -40345,7 +40510,7 @@
         </p:nvGraphicFramePr>
         <p:xfrm>
           <a:off x="822960" y="1143000"/>
-          <a:ext cx="5532120" cy="5833872"/>
+          <a:ext cx="5532119" cy="5120640"/>
         </p:xfrm>
         <a:graphic>
           <a:graphicData uri="http://schemas.openxmlformats.org/drawingml/2006/table">
@@ -40354,8 +40519,8 @@
                 <a:tableStyleId>{5C22544A-7EE6-4342-B048-85BDC9FD1C3A}</a:tableStyleId>
               </a:tblPr>
               <a:tblGrid>
-                <a:gridCol w="2212848"/>
-                <a:gridCol w="3319272"/>
+                <a:gridCol w="663854"/>
+                <a:gridCol w="4868265"/>
               </a:tblGrid>
               <a:tr h="365760">
                 <a:tc>
@@ -40417,7 +40582,7 @@
                   </a:tcPr>
                 </a:tc>
               </a:tr>
-              <a:tr h="420624">
+              <a:tr h="365760">
                 <a:tc>
                   <a:txBody>
                     <a:bodyPr wrap="square"/>
@@ -40477,7 +40642,7 @@
                   </a:tcPr>
                 </a:tc>
               </a:tr>
-              <a:tr h="420624">
+              <a:tr h="365760">
                 <a:tc>
                   <a:txBody>
                     <a:bodyPr wrap="square"/>
@@ -40537,7 +40702,7 @@
                   </a:tcPr>
                 </a:tc>
               </a:tr>
-              <a:tr h="420624">
+              <a:tr h="365760">
                 <a:tc>
                   <a:txBody>
                     <a:bodyPr wrap="square"/>
@@ -40597,7 +40762,7 @@
                   </a:tcPr>
                 </a:tc>
               </a:tr>
-              <a:tr h="420624">
+              <a:tr h="365760">
                 <a:tc>
                   <a:txBody>
                     <a:bodyPr wrap="square"/>
@@ -40657,7 +40822,7 @@
                   </a:tcPr>
                 </a:tc>
               </a:tr>
-              <a:tr h="420624">
+              <a:tr h="365760">
                 <a:tc>
                   <a:txBody>
                     <a:bodyPr wrap="square"/>
@@ -40717,7 +40882,7 @@
                   </a:tcPr>
                 </a:tc>
               </a:tr>
-              <a:tr h="420624">
+              <a:tr h="365760">
                 <a:tc>
                   <a:txBody>
                     <a:bodyPr wrap="square"/>
@@ -40777,7 +40942,7 @@
                   </a:tcPr>
                 </a:tc>
               </a:tr>
-              <a:tr h="420624">
+              <a:tr h="365760">
                 <a:tc>
                   <a:txBody>
                     <a:bodyPr wrap="square"/>
@@ -40837,7 +41002,7 @@
                   </a:tcPr>
                 </a:tc>
               </a:tr>
-              <a:tr h="420624">
+              <a:tr h="365760">
                 <a:tc>
                   <a:txBody>
                     <a:bodyPr wrap="square"/>
@@ -40897,7 +41062,7 @@
                   </a:tcPr>
                 </a:tc>
               </a:tr>
-              <a:tr h="420624">
+              <a:tr h="365760">
                 <a:tc>
                   <a:txBody>
                     <a:bodyPr wrap="square"/>
@@ -40957,7 +41122,7 @@
                   </a:tcPr>
                 </a:tc>
               </a:tr>
-              <a:tr h="420624">
+              <a:tr h="365760">
                 <a:tc>
                   <a:txBody>
                     <a:bodyPr wrap="square"/>
@@ -41017,7 +41182,7 @@
                   </a:tcPr>
                 </a:tc>
               </a:tr>
-              <a:tr h="420624">
+              <a:tr h="365760">
                 <a:tc>
                   <a:txBody>
                     <a:bodyPr wrap="square"/>
@@ -41077,7 +41242,7 @@
                   </a:tcPr>
                 </a:tc>
               </a:tr>
-              <a:tr h="420624">
+              <a:tr h="365760">
                 <a:tc>
                   <a:txBody>
                     <a:bodyPr wrap="square"/>
@@ -41137,7 +41302,7 @@
                   </a:tcPr>
                 </a:tc>
               </a:tr>
-              <a:tr h="420624">
+              <a:tr h="365760">
                 <a:tc>
                   <a:txBody>
                     <a:bodyPr wrap="square"/>
@@ -41211,7 +41376,7 @@
         </p:nvGraphicFramePr>
         <p:xfrm>
           <a:off x="6812280" y="1143000"/>
-          <a:ext cx="5532120" cy="5833872"/>
+          <a:ext cx="5532119" cy="5120640"/>
         </p:xfrm>
         <a:graphic>
           <a:graphicData uri="http://schemas.openxmlformats.org/drawingml/2006/table">
@@ -41220,8 +41385,8 @@
                 <a:tableStyleId>{5C22544A-7EE6-4342-B048-85BDC9FD1C3A}</a:tableStyleId>
               </a:tblPr>
               <a:tblGrid>
-                <a:gridCol w="2212848"/>
-                <a:gridCol w="3319272"/>
+                <a:gridCol w="663854"/>
+                <a:gridCol w="4868265"/>
               </a:tblGrid>
               <a:tr h="365760">
                 <a:tc>
@@ -41283,7 +41448,7 @@
                   </a:tcPr>
                 </a:tc>
               </a:tr>
-              <a:tr h="420624">
+              <a:tr h="365760">
                 <a:tc>
                   <a:txBody>
                     <a:bodyPr wrap="square"/>
@@ -41343,7 +41508,7 @@
                   </a:tcPr>
                 </a:tc>
               </a:tr>
-              <a:tr h="420624">
+              <a:tr h="365760">
                 <a:tc>
                   <a:txBody>
                     <a:bodyPr wrap="square"/>
@@ -41403,7 +41568,7 @@
                   </a:tcPr>
                 </a:tc>
               </a:tr>
-              <a:tr h="420624">
+              <a:tr h="365760">
                 <a:tc>
                   <a:txBody>
                     <a:bodyPr wrap="square"/>
@@ -41463,7 +41628,7 @@
                   </a:tcPr>
                 </a:tc>
               </a:tr>
-              <a:tr h="420624">
+              <a:tr h="365760">
                 <a:tc>
                   <a:txBody>
                     <a:bodyPr wrap="square"/>
@@ -41523,7 +41688,7 @@
                   </a:tcPr>
                 </a:tc>
               </a:tr>
-              <a:tr h="420624">
+              <a:tr h="365760">
                 <a:tc>
                   <a:txBody>
                     <a:bodyPr wrap="square"/>
@@ -41583,7 +41748,7 @@
                   </a:tcPr>
                 </a:tc>
               </a:tr>
-              <a:tr h="420624">
+              <a:tr h="365760">
                 <a:tc>
                   <a:txBody>
                     <a:bodyPr wrap="square"/>
@@ -41643,7 +41808,7 @@
                   </a:tcPr>
                 </a:tc>
               </a:tr>
-              <a:tr h="420624">
+              <a:tr h="365760">
                 <a:tc>
                   <a:txBody>
                     <a:bodyPr wrap="square"/>
@@ -41703,7 +41868,7 @@
                   </a:tcPr>
                 </a:tc>
               </a:tr>
-              <a:tr h="420624">
+              <a:tr h="365760">
                 <a:tc>
                   <a:txBody>
                     <a:bodyPr wrap="square"/>
@@ -41763,7 +41928,7 @@
                   </a:tcPr>
                 </a:tc>
               </a:tr>
-              <a:tr h="420624">
+              <a:tr h="365760">
                 <a:tc>
                   <a:txBody>
                     <a:bodyPr wrap="square"/>
@@ -41823,7 +41988,7 @@
                   </a:tcPr>
                 </a:tc>
               </a:tr>
-              <a:tr h="420624">
+              <a:tr h="365760">
                 <a:tc>
                   <a:txBody>
                     <a:bodyPr wrap="square"/>
@@ -41883,7 +42048,7 @@
                   </a:tcPr>
                 </a:tc>
               </a:tr>
-              <a:tr h="420624">
+              <a:tr h="365760">
                 <a:tc>
                   <a:txBody>
                     <a:bodyPr wrap="square"/>
@@ -41943,7 +42108,7 @@
                   </a:tcPr>
                 </a:tc>
               </a:tr>
-              <a:tr h="420624">
+              <a:tr h="365760">
                 <a:tc>
                   <a:txBody>
                     <a:bodyPr wrap="square"/>
@@ -42003,7 +42168,7 @@
                   </a:tcPr>
                 </a:tc>
               </a:tr>
-              <a:tr h="420624">
+              <a:tr h="365760">
                 <a:tc>
                   <a:txBody>
                     <a:bodyPr wrap="square"/>
@@ -42075,7 +42240,7 @@
         </p:nvSpPr>
         <p:spPr>
           <a:xfrm>
-            <a:off x="822960" y="6446520"/>
+            <a:off x="822960" y="6492240"/>
             <a:ext cx="11793855" cy="274320"/>
           </a:xfrm>
           <a:prstGeom prst="rect">

</xml_diff>

<commit_message>
Fix template deck: remove empty inherited placeholders (root cause of slide-1 overlap)
- テンプレートのレイアウト由来で複製される“空プレースホルダ”を全スライドから削除。
  特に表紙は同一座標(1.39,5.52)に本文プレースホルダが2枚あり重なっていた（1枚目の
  重なりの原因）。空文字化では消えないため要素ごと削除する処理を追加
- 継承プレースホルダを含む全シェイプ対象の幾何監査を追加：空枠0/領域外0/重なり0 を確認
- 内容・配色・レイアウト適用（表紙/セクション/本文）・全量は不変

Co-Authored-By: Claude Opus 4.8 <noreply@anthropic.com>
Claude-Session: https://claude.ai/code/session_01UBcUziZuoBuQPVuVkCwg3R
</commit_message>
<xml_diff>
--- a/sharepoint-online-guide/SharePoint-Online活用ガイド_フェーズ1-4.pptx
+++ b/sharepoint-online-guide/SharePoint-Online活用ガイド_フェーズ1-4.pptx
@@ -10798,23 +10798,6 @@
           </a:p>
         </p:txBody>
       </p:sp>
-      <p:sp>
-        <p:nvSpPr>
-          <p:cNvPr id="6" name="Text Placeholder 5"/>
-          <p:cNvSpPr>
-            <a:spLocks noGrp="1"/>
-          </p:cNvSpPr>
-          <p:nvPr>
-            <p:ph type="body" idx="10" sz="half"/>
-          </p:nvPr>
-        </p:nvSpPr>
-        <p:spPr/>
-        <p:txBody>
-          <a:bodyPr/>
-          <a:lstStyle/>
-          <a:p/>
-        </p:txBody>
-      </p:sp>
     </p:spTree>
   </p:cSld>
   <p:clrMapOvr>
@@ -21625,23 +21608,6 @@
       <p:grpSpPr/>
       <p:sp>
         <p:nvSpPr>
-          <p:cNvPr id="2" name="Text Placeholder 1"/>
-          <p:cNvSpPr>
-            <a:spLocks noGrp="1"/>
-          </p:cNvSpPr>
-          <p:nvPr>
-            <p:ph type="body" idx="13" sz="quarter"/>
-          </p:nvPr>
-        </p:nvSpPr>
-        <p:spPr/>
-        <p:txBody>
-          <a:bodyPr/>
-          <a:lstStyle/>
-          <a:p/>
-        </p:txBody>
-      </p:sp>
-      <p:sp>
-        <p:nvSpPr>
           <p:cNvPr id="3" name="Title 2"/>
           <p:cNvSpPr>
             <a:spLocks noGrp="1"/>
@@ -27561,23 +27527,6 @@
       <p:grpSpPr/>
       <p:sp>
         <p:nvSpPr>
-          <p:cNvPr id="2" name="Text Placeholder 1"/>
-          <p:cNvSpPr>
-            <a:spLocks noGrp="1"/>
-          </p:cNvSpPr>
-          <p:nvPr>
-            <p:ph type="body" idx="13" sz="quarter"/>
-          </p:nvPr>
-        </p:nvSpPr>
-        <p:spPr/>
-        <p:txBody>
-          <a:bodyPr/>
-          <a:lstStyle/>
-          <a:p/>
-        </p:txBody>
-      </p:sp>
-      <p:sp>
-        <p:nvSpPr>
           <p:cNvPr id="3" name="Title 2"/>
           <p:cNvSpPr>
             <a:spLocks noGrp="1"/>
@@ -31563,23 +31512,6 @@
         <p:nvPr/>
       </p:nvGrpSpPr>
       <p:grpSpPr/>
-      <p:sp>
-        <p:nvSpPr>
-          <p:cNvPr id="2" name="Text Placeholder 1"/>
-          <p:cNvSpPr>
-            <a:spLocks noGrp="1"/>
-          </p:cNvSpPr>
-          <p:nvPr>
-            <p:ph type="body" idx="13" sz="quarter"/>
-          </p:nvPr>
-        </p:nvSpPr>
-        <p:spPr/>
-        <p:txBody>
-          <a:bodyPr/>
-          <a:lstStyle/>
-          <a:p/>
-        </p:txBody>
-      </p:sp>
       <p:sp>
         <p:nvSpPr>
           <p:cNvPr id="3" name="Title 2"/>
@@ -39756,23 +39688,6 @@
         <p:nvPr/>
       </p:nvGrpSpPr>
       <p:grpSpPr/>
-      <p:sp>
-        <p:nvSpPr>
-          <p:cNvPr id="2" name="Text Placeholder 1"/>
-          <p:cNvSpPr>
-            <a:spLocks noGrp="1"/>
-          </p:cNvSpPr>
-          <p:nvPr>
-            <p:ph type="body" idx="13" sz="quarter"/>
-          </p:nvPr>
-        </p:nvSpPr>
-        <p:spPr/>
-        <p:txBody>
-          <a:bodyPr/>
-          <a:lstStyle/>
-          <a:p/>
-        </p:txBody>
-      </p:sp>
       <p:sp>
         <p:nvSpPr>
           <p:cNvPr id="3" name="Title 2"/>

</xml_diff>